<commit_message>
Brand presentation with candidate details
</commit_message>
<xml_diff>
--- a/presentation/last_mile_logistics_auditor_presentation.pptx
+++ b/presentation/last_mile_logistics_auditor_presentation.pptx
@@ -3162,7 +3162,7 @@
             <a:br/>
             <a:r>
               <a:rPr/>
-              <a:t>Veridi Logistics Audit</a:t>
+              <a:t>Irigenera Alliance | AIMS Rwanda | AmaliTech Rwanda Exam Task</a:t>
             </a:r>
           </a:p>
         </p:txBody>
@@ -3546,6 +3546,37 @@
             <a:r>
               <a:rPr/>
               <a:t>Delivery promise accuracy and customer sentiment audit for Veridi Logistics.</a:t>
+            </a:r>
+          </a:p>
+          <a:p>
+            <a:pPr lvl="0" indent="0" marL="0">
+              <a:buNone/>
+            </a:pPr>
+            <a:r>
+              <a:rPr/>
+              <a:t>Prepared by </a:t>
+            </a:r>
+            <a:r>
+              <a:rPr b="1"/>
+              <a:t>Irigenera Alliance</a:t>
+            </a:r>
+            <a:br/>
+            <a:r>
+              <a:rPr/>
+              <a:t>Student at </a:t>
+            </a:r>
+            <a:r>
+              <a:rPr b="1"/>
+              <a:t>AIMS Rwanda</a:t>
+            </a:r>
+            <a:br/>
+            <a:r>
+              <a:rPr/>
+              <a:t>Exam task for </a:t>
+            </a:r>
+            <a:r>
+              <a:rPr b="1"/>
+              <a:t>AmaliTech Rwanda</a:t>
             </a:r>
           </a:p>
           <a:p>

</xml_diff>